<commit_message>
Fix hardcoded security slide
</commit_message>
<xml_diff>
--- a/tests/report_generator/integration/references/reference_portfolio-overview.pptx
+++ b/tests/report_generator/integration/references/reference_portfolio-overview.pptx
@@ -37380,7 +37380,7 @@
           <a:p>
             <a:r>
               <a:rPr lang="en-GB" dirty="0"/>
-              <a:t>The portfolio's maintainability has increased (with 2.5 to 2.5) during the measured period</a:t>
+              <a:t>The portfolio's maintainability has decreased (with -0.7 to 2.5) during the measured period</a:t>
             </a:r>
           </a:p>
         </p:txBody>
@@ -38101,7 +38101,7 @@
                 <a:ea typeface="Calibri"/>
                 <a:cs typeface="Calibri"/>
               </a:rPr>
-              <a:t>17% of systems has seen an increase in maintainability. 0% of systems has remained stable. 83% of systems has seen a decrease in maintainability.</a:t>
+              <a:t>8% of systems has seen an increase in maintainability. 8% of systems has remained stable. 83% of systems has seen a decrease in maintainability.</a:t>
             </a:r>
           </a:p>
           <a:p>
@@ -41037,7 +41037,7 @@
             <a:pPr indent="-283845"/>
             <a:r>
               <a:rPr lang="en-GB" sz="1550" noProof="0" dirty="0"/>
-              <a:t>Overall, there has been a decrease in test code ratio for the portfolio (-2.4%).</a:t>
+              <a:t>Overall, there has been a decrease in test code ratio for the portfolio (-2.3%).</a:t>
             </a:r>
             <a:endParaRPr lang="en-GB" sz="1550" noProof="0" dirty="0"/>
           </a:p>
@@ -41052,7 +41052,7 @@
             <a:pPr indent="-283845"/>
             <a:r>
               <a:rPr lang="en-GB" sz="1550" dirty="0"/>
-              <a:t>The largest increase in test code ratio was experienced by integrationtest-zuul (+3.3%). The largest decrease in test code ratio was experienced by integrationtest-jruby (-23.4%).</a:t>
+              <a:t>The largest increase in test code ratio was experienced by integrationtest-zuul (+3.9%). The largest decrease in test code ratio was experienced by integrationtest-jruby (-23.4%).</a:t>
             </a:r>
             <a:endParaRPr lang="en-GB" sz="1550" dirty="0">
               <a:ea typeface="Calibri"/>
@@ -42184,21 +42184,21 @@
             <a:pPr indent="-283845"/>
             <a:r>
               <a:rPr lang="en-US" dirty="0"/>
-              <a:t>38% of systems score above market average for Architecture Quality (≥3.5★).</a:t>
+              <a:t>33% of systems score above market average for Architecture Quality (≥3.5★).</a:t>
             </a:r>
           </a:p>
           <a:p>
             <a:pPr indent="-283845"/>
             <a:r>
               <a:rPr lang="en-US" dirty="0"/>
-              <a:t>31% of systems score market average for Architecture Quality (3★).</a:t>
+              <a:t>33% of systems score market average for Architecture Quality (3★).</a:t>
             </a:r>
           </a:p>
           <a:p>
             <a:pPr indent="-283845"/>
             <a:r>
               <a:rPr lang="en-US" dirty="0"/>
-              <a:t>31% of systems score below market average for Architecture Quality (≤2.5★).</a:t>
+              <a:t>33% of systems score below market average for Architecture Quality (≤2.5★).</a:t>
             </a:r>
           </a:p>
         </p:txBody>
@@ -43889,7 +43889,7 @@
           <a:p>
             <a:r>
               <a:rPr lang="en-US" b="0" dirty="0"/>
-              <a:t>826</a:t>
+              <a:t>821</a:t>
             </a:r>
           </a:p>
         </p:txBody>

</xml_diff>

<commit_message>
fix integration portfolio overview
</commit_message>
<xml_diff>
--- a/tests/report_generator/integration/references/reference_portfolio-overview.pptx
+++ b/tests/report_generator/integration/references/reference_portfolio-overview.pptx
@@ -45197,7 +45197,7 @@
             <a:pPr indent="-283845"/>
             <a:r>
               <a:rPr lang="en-US" dirty="0"/>
-              <a:t>The average Security rating for the portfolio is 2.0</a:t>
+              <a:t>The average Security rating for the portfolio is 1.8</a:t>
             </a:r>
             <a:r>
               <a:rPr lang="en-US" sz="100" dirty="0"/>
@@ -45212,21 +45212,21 @@
             <a:pPr indent="-283845"/>
             <a:r>
               <a:rPr lang="en-GB" dirty="0"/>
-              <a:t>17% of systems score above market average for Security (≥3.5★).</a:t>
+              <a:t>8% of systems score above market average for Security (≥3.5★).</a:t>
             </a:r>
           </a:p>
           <a:p>
             <a:pPr indent="-283845"/>
             <a:r>
               <a:rPr lang="en-US" dirty="0"/>
-              <a:t>33% of systems score market average for Security (3★).</a:t>
+              <a:t>25% of systems score market average for Security (3★).</a:t>
             </a:r>
           </a:p>
           <a:p>
             <a:pPr indent="-283845"/>
             <a:r>
               <a:rPr lang="en-US" dirty="0"/>
-              <a:t>50% of systems score below market average for Security(≤2.5★).</a:t>
+              <a:t>67% of systems score below market average for Security(≤2.5★).</a:t>
             </a:r>
           </a:p>
         </p:txBody>

</xml_diff>